<commit_message>
Rebrand assets: new wax-seal + Ionic-column logo; remove old seal-P set; wire into deck + README
New Precedent logo (wax seal enclosing a classical Ionic column + PRECEDENT wordmark, indigo
#3C3B62 on cream #F1F1E2). Replaces the old untracked seal-P system entirely.

- assets/brand/: colored + transparent logo (SVG masters + PDF), a 640px web PNG, a generated
  dark-background seal mark (cream column reads on the dark deck — flood-filled transparent bg),
  a square Agentverse avatar, and a rewritten brand README. All old logo files removed.
- Deck: the dark seal now heads the title slide (both submission + stage PDFs rebuilt); export
  still clean (22 pages, 0 ‹, 0 [[WAIT, no "Autonomous", all numbers intact).
- README: a <picture> that shows the colored logo on light GitHub themes and the dark seal on dark.

Brand assets are now tracked (committed) so the README image resolves on the public repo.

Co-Authored-By: Claude Opus 4.8 <noreply@anthropic.com>
</commit_message>
<xml_diff>
--- a/docs/deck/precedent-deck-stage.pptx
+++ b/docs/deck/precedent-deck-stage.pptx
@@ -4342,16 +4342,40 @@
           </a:p>
         </p:txBody>
       </p:sp>
-      <p:sp>
-        <p:nvSpPr>
-          <p:cNvPr id="3" name="TextBox 2"/>
+      <p:pic>
+        <p:nvPicPr>
+          <p:cNvPr id="3" name="Picture 2" descr="precedent-seal-dark.png"/>
+          <p:cNvPicPr>
+            <a:picLocks noChangeAspect="1"/>
+          </p:cNvPicPr>
+          <p:nvPr/>
+        </p:nvPicPr>
+        <p:blipFill>
+          <a:blip r:embed="rId2"/>
+          <a:stretch>
+            <a:fillRect/>
+          </a:stretch>
+        </p:blipFill>
+        <p:spPr>
+          <a:xfrm>
+            <a:off x="4813706" y="502920"/>
+            <a:ext cx="2564283" cy="2514600"/>
+          </a:xfrm>
+          <a:prstGeom prst="rect">
+            <a:avLst/>
+          </a:prstGeom>
+        </p:spPr>
+      </p:pic>
+      <p:sp>
+        <p:nvSpPr>
+          <p:cNvPr id="4" name="TextBox 3"/>
           <p:cNvSpPr txBox="1"/>
           <p:nvPr/>
         </p:nvSpPr>
         <p:spPr>
           <a:xfrm>
-            <a:off x="914400" y="2194560"/>
-            <a:ext cx="10332720" cy="2011680"/>
+            <a:off x="914400" y="3200400"/>
+            <a:ext cx="10332720" cy="1737360"/>
           </a:xfrm>
           <a:prstGeom prst="rect">
             <a:avLst/>
@@ -4366,7 +4390,7 @@
           <a:p>
             <a:pPr algn="ctr"/>
             <a:r>
-              <a:rPr sz="8000" b="1">
+              <a:rPr sz="6600" b="1">
                 <a:solidFill>
                   <a:srgbClr val="E6E6E6"/>
                 </a:solidFill>
@@ -4378,7 +4402,7 @@
           <a:p>
             <a:pPr algn="ctr"/>
             <a:r>
-              <a:rPr sz="2600" b="0">
+              <a:rPr sz="2400" b="0">
                 <a:solidFill>
                   <a:srgbClr val="34D399"/>
                 </a:solidFill>
@@ -4391,13 +4415,13 @@
       </p:sp>
       <p:sp>
         <p:nvSpPr>
-          <p:cNvPr id="4" name="TextBox 3"/>
+          <p:cNvPr id="5" name="TextBox 4"/>
           <p:cNvSpPr txBox="1"/>
           <p:nvPr/>
         </p:nvSpPr>
         <p:spPr>
           <a:xfrm>
-            <a:off x="914400" y="5669280"/>
+            <a:off x="914400" y="5989320"/>
             <a:ext cx="10332720" cy="548640"/>
           </a:xfrm>
           <a:prstGeom prst="rect">

</xml_diff>

<commit_message>
Remove the dark logo variant (precedent-seal-dark.png)
A cream logo card reads as a sticker on the dark deck, so the dark recolored seal was the only
way to put the mark there — dropping it, the deck title returns to the clean wordmark-only layout.

- Deleted assets/brand/precedent-seal-dark.png.
- Deck title slide reverted to text-only wordmark (both PDFs rebuilt, still clean).
- README uses the colored logo for all themes (no <picture> dark source).
- Brand README updated: logo stays on light surfaces; the dark deck is wordmark-only.

Co-Authored-By: Claude Opus 4.8 <noreply@anthropic.com>
</commit_message>
<xml_diff>
--- a/docs/deck/precedent-deck-stage.pptx
+++ b/docs/deck/precedent-deck-stage.pptx
@@ -4342,40 +4342,16 @@
           </a:p>
         </p:txBody>
       </p:sp>
-      <p:pic>
-        <p:nvPicPr>
-          <p:cNvPr id="3" name="Picture 2" descr="precedent-seal-dark.png"/>
-          <p:cNvPicPr>
-            <a:picLocks noChangeAspect="1"/>
-          </p:cNvPicPr>
-          <p:nvPr/>
-        </p:nvPicPr>
-        <p:blipFill>
-          <a:blip r:embed="rId2"/>
-          <a:stretch>
-            <a:fillRect/>
-          </a:stretch>
-        </p:blipFill>
-        <p:spPr>
-          <a:xfrm>
-            <a:off x="4813706" y="502920"/>
-            <a:ext cx="2564283" cy="2514600"/>
-          </a:xfrm>
-          <a:prstGeom prst="rect">
-            <a:avLst/>
-          </a:prstGeom>
-        </p:spPr>
-      </p:pic>
-      <p:sp>
-        <p:nvSpPr>
-          <p:cNvPr id="4" name="TextBox 3"/>
+      <p:sp>
+        <p:nvSpPr>
+          <p:cNvPr id="3" name="TextBox 2"/>
           <p:cNvSpPr txBox="1"/>
           <p:nvPr/>
         </p:nvSpPr>
         <p:spPr>
           <a:xfrm>
-            <a:off x="914400" y="3200400"/>
-            <a:ext cx="10332720" cy="1737360"/>
+            <a:off x="914400" y="2194560"/>
+            <a:ext cx="10332720" cy="2011680"/>
           </a:xfrm>
           <a:prstGeom prst="rect">
             <a:avLst/>
@@ -4390,7 +4366,7 @@
           <a:p>
             <a:pPr algn="ctr"/>
             <a:r>
-              <a:rPr sz="6600" b="1">
+              <a:rPr sz="8000" b="1">
                 <a:solidFill>
                   <a:srgbClr val="E6E6E6"/>
                 </a:solidFill>
@@ -4402,7 +4378,7 @@
           <a:p>
             <a:pPr algn="ctr"/>
             <a:r>
-              <a:rPr sz="2400" b="0">
+              <a:rPr sz="2600" b="0">
                 <a:solidFill>
                   <a:srgbClr val="34D399"/>
                 </a:solidFill>
@@ -4415,13 +4391,13 @@
       </p:sp>
       <p:sp>
         <p:nvSpPr>
-          <p:cNvPr id="5" name="TextBox 4"/>
+          <p:cNvPr id="4" name="TextBox 3"/>
           <p:cNvSpPr txBox="1"/>
           <p:nvPr/>
         </p:nvSpPr>
         <p:spPr>
           <a:xfrm>
-            <a:off x="914400" y="5989320"/>
+            <a:off x="914400" y="5669280"/>
             <a:ext cx="10332720" cy="548640"/>
           </a:xfrm>
           <a:prstGeom prst="rect">

</xml_diff>